<commit_message>
Update slides with bacteria.gif
</commit_message>
<xml_diff>
--- a/Lecture3/IntroProgrammingPart3.pptx
+++ b/Lecture3/IntroProgrammingPart3.pptx
@@ -6,11 +6,12 @@
   </p:sldMasterIdLst>
   <p:sldIdLst>
     <p:sldId id="256" r:id="rId2"/>
-    <p:sldId id="259" r:id="rId3"/>
-    <p:sldId id="257" r:id="rId4"/>
-    <p:sldId id="260" r:id="rId5"/>
-    <p:sldId id="258" r:id="rId6"/>
-    <p:sldId id="261" r:id="rId7"/>
+    <p:sldId id="262" r:id="rId3"/>
+    <p:sldId id="259" r:id="rId4"/>
+    <p:sldId id="257" r:id="rId5"/>
+    <p:sldId id="260" r:id="rId6"/>
+    <p:sldId id="258" r:id="rId7"/>
+    <p:sldId id="261" r:id="rId8"/>
   </p:sldIdLst>
   <p:sldSz cx="12192000" cy="6858000"/>
   <p:notesSz cx="6858000" cy="9144000"/>
@@ -1721,7 +1722,7 @@
           <a:p>
             <a:fld id="{846CE7D5-CF57-46EF-B807-FDD0502418D4}" type="datetimeFigureOut">
               <a:rPr lang="en-US" smtClean="0"/>
-              <a:t>6/24/24</a:t>
+              <a:t>6/18/26</a:t>
             </a:fld>
             <a:endParaRPr lang="en-US"/>
           </a:p>
@@ -1891,7 +1892,7 @@
           <a:p>
             <a:fld id="{846CE7D5-CF57-46EF-B807-FDD0502418D4}" type="datetimeFigureOut">
               <a:rPr lang="en-US" smtClean="0"/>
-              <a:t>6/24/24</a:t>
+              <a:t>6/18/26</a:t>
             </a:fld>
             <a:endParaRPr lang="en-US"/>
           </a:p>
@@ -2071,7 +2072,7 @@
           <a:p>
             <a:fld id="{846CE7D5-CF57-46EF-B807-FDD0502418D4}" type="datetimeFigureOut">
               <a:rPr lang="en-US" smtClean="0"/>
-              <a:t>6/24/24</a:t>
+              <a:t>6/18/26</a:t>
             </a:fld>
             <a:endParaRPr lang="en-US"/>
           </a:p>
@@ -2241,7 +2242,7 @@
           <a:p>
             <a:fld id="{846CE7D5-CF57-46EF-B807-FDD0502418D4}" type="datetimeFigureOut">
               <a:rPr lang="en-US" smtClean="0"/>
-              <a:t>6/24/24</a:t>
+              <a:t>6/18/26</a:t>
             </a:fld>
             <a:endParaRPr lang="en-US"/>
           </a:p>
@@ -2487,7 +2488,7 @@
           <a:p>
             <a:fld id="{846CE7D5-CF57-46EF-B807-FDD0502418D4}" type="datetimeFigureOut">
               <a:rPr lang="en-US" smtClean="0"/>
-              <a:t>6/24/24</a:t>
+              <a:t>6/18/26</a:t>
             </a:fld>
             <a:endParaRPr lang="en-US"/>
           </a:p>
@@ -2719,7 +2720,7 @@
           <a:p>
             <a:fld id="{846CE7D5-CF57-46EF-B807-FDD0502418D4}" type="datetimeFigureOut">
               <a:rPr lang="en-US" smtClean="0"/>
-              <a:t>6/24/24</a:t>
+              <a:t>6/18/26</a:t>
             </a:fld>
             <a:endParaRPr lang="en-US"/>
           </a:p>
@@ -3086,7 +3087,7 @@
           <a:p>
             <a:fld id="{846CE7D5-CF57-46EF-B807-FDD0502418D4}" type="datetimeFigureOut">
               <a:rPr lang="en-US" smtClean="0"/>
-              <a:t>6/24/24</a:t>
+              <a:t>6/18/26</a:t>
             </a:fld>
             <a:endParaRPr lang="en-US"/>
           </a:p>
@@ -3204,7 +3205,7 @@
           <a:p>
             <a:fld id="{846CE7D5-CF57-46EF-B807-FDD0502418D4}" type="datetimeFigureOut">
               <a:rPr lang="en-US" smtClean="0"/>
-              <a:t>6/24/24</a:t>
+              <a:t>6/18/26</a:t>
             </a:fld>
             <a:endParaRPr lang="en-US"/>
           </a:p>
@@ -3299,7 +3300,7 @@
           <a:p>
             <a:fld id="{846CE7D5-CF57-46EF-B807-FDD0502418D4}" type="datetimeFigureOut">
               <a:rPr lang="en-US" smtClean="0"/>
-              <a:t>6/24/24</a:t>
+              <a:t>6/18/26</a:t>
             </a:fld>
             <a:endParaRPr lang="en-US"/>
           </a:p>
@@ -3576,7 +3577,7 @@
           <a:p>
             <a:fld id="{846CE7D5-CF57-46EF-B807-FDD0502418D4}" type="datetimeFigureOut">
               <a:rPr lang="en-US" smtClean="0"/>
-              <a:t>6/24/24</a:t>
+              <a:t>6/18/26</a:t>
             </a:fld>
             <a:endParaRPr lang="en-US"/>
           </a:p>
@@ -3833,7 +3834,7 @@
           <a:p>
             <a:fld id="{846CE7D5-CF57-46EF-B807-FDD0502418D4}" type="datetimeFigureOut">
               <a:rPr lang="en-US" smtClean="0"/>
-              <a:t>6/24/24</a:t>
+              <a:t>6/18/26</a:t>
             </a:fld>
             <a:endParaRPr lang="en-US"/>
           </a:p>
@@ -4046,7 +4047,7 @@
           <a:p>
             <a:fld id="{846CE7D5-CF57-46EF-B807-FDD0502418D4}" type="datetimeFigureOut">
               <a:rPr lang="en-US" smtClean="0"/>
-              <a:t>6/24/24</a:t>
+              <a:t>6/18/26</a:t>
             </a:fld>
             <a:endParaRPr lang="en-US"/>
           </a:p>
@@ -4484,16 +4485,12 @@
               <a:rPr lang="en-US" sz="4800" dirty="0"/>
             </a:br>
             <a:r>
+              <a:rPr lang="en-US" sz="4800" dirty="0" err="1"/>
+              <a:t>Numpy</a:t>
+            </a:r>
+            <a:r>
               <a:rPr lang="en-US" sz="4800" dirty="0"/>
-              <a:t>For loops, </a:t>
-            </a:r>
-            <a:r>
-              <a:rPr lang="en-US" sz="4800" dirty="0" err="1"/>
-              <a:t>numpy</a:t>
-            </a:r>
-            <a:r>
-              <a:rPr lang="en-US" sz="4800" dirty="0"/>
-              <a:t> arrays, </a:t>
+              <a:t> arrays</a:t>
             </a:r>
             <a:br>
               <a:rPr lang="en-US" sz="4800" dirty="0"/>
@@ -4532,8 +4529,13 @@
           <a:p>
             <a:r>
               <a:rPr lang="en-US" dirty="0"/>
-              <a:t>Keisuke Ishihara</a:t>
-            </a:r>
+              <a:t>Keisuke Ishihara, Chris Morii-</a:t>
+            </a:r>
+            <a:r>
+              <a:rPr lang="en-US" dirty="0" err="1"/>
+              <a:t>Sciolla</a:t>
+            </a:r>
+            <a:endParaRPr lang="en-US" dirty="0"/>
           </a:p>
         </p:txBody>
       </p:sp>
@@ -4551,6 +4553,218 @@
 </file>
 
 <file path=ppt/slides/slide2.xml><?xml version="1.0" encoding="utf-8"?>
+<p:sld xmlns:a="http://schemas.openxmlformats.org/drawingml/2006/main" xmlns:r="http://schemas.openxmlformats.org/officeDocument/2006/relationships" xmlns:p="http://schemas.openxmlformats.org/presentationml/2006/main">
+  <p:cSld>
+    <p:spTree>
+      <p:nvGrpSpPr>
+        <p:cNvPr id="1" name=""/>
+        <p:cNvGrpSpPr/>
+        <p:nvPr/>
+      </p:nvGrpSpPr>
+      <p:grpSpPr>
+        <a:xfrm>
+          <a:off x="0" y="0"/>
+          <a:ext cx="0" cy="0"/>
+          <a:chOff x="0" y="0"/>
+          <a:chExt cx="0" cy="0"/>
+        </a:xfrm>
+      </p:grpSpPr>
+      <p:sp>
+        <p:nvSpPr>
+          <p:cNvPr id="2" name="Title 1">
+            <a:extLst>
+              <a:ext uri="{FF2B5EF4-FFF2-40B4-BE49-F238E27FC236}">
+                <a16:creationId xmlns:a16="http://schemas.microsoft.com/office/drawing/2014/main" id="{63F3F287-820D-FFE0-2C99-0B78559C169B}"/>
+              </a:ext>
+            </a:extLst>
+          </p:cNvPr>
+          <p:cNvSpPr>
+            <a:spLocks noGrp="1"/>
+          </p:cNvSpPr>
+          <p:nvPr>
+            <p:ph type="title"/>
+          </p:nvPr>
+        </p:nvSpPr>
+        <p:spPr>
+          <a:xfrm>
+            <a:off x="838200" y="365125"/>
+            <a:ext cx="10515600" cy="845837"/>
+          </a:xfrm>
+        </p:spPr>
+        <p:txBody>
+          <a:bodyPr/>
+          <a:lstStyle/>
+          <a:p>
+            <a:r>
+              <a:rPr lang="en-US" dirty="0"/>
+              <a:t>Tracking bacterial growth (and death)</a:t>
+            </a:r>
+          </a:p>
+        </p:txBody>
+      </p:sp>
+      <p:sp>
+        <p:nvSpPr>
+          <p:cNvPr id="4" name="TextBox 3">
+            <a:extLst>
+              <a:ext uri="{FF2B5EF4-FFF2-40B4-BE49-F238E27FC236}">
+                <a16:creationId xmlns:a16="http://schemas.microsoft.com/office/drawing/2014/main" id="{A8419680-79E9-9344-B5ED-5E0F0255B4FB}"/>
+              </a:ext>
+            </a:extLst>
+          </p:cNvPr>
+          <p:cNvSpPr txBox="1"/>
+          <p:nvPr/>
+        </p:nvSpPr>
+        <p:spPr>
+          <a:xfrm>
+            <a:off x="1552195" y="6338986"/>
+            <a:ext cx="5770607" cy="307777"/>
+          </a:xfrm>
+          <a:prstGeom prst="rect">
+            <a:avLst/>
+          </a:prstGeom>
+          <a:noFill/>
+        </p:spPr>
+        <p:txBody>
+          <a:bodyPr wrap="square" rtlCol="0">
+            <a:spAutoFit/>
+          </a:bodyPr>
+          <a:lstStyle/>
+          <a:p>
+            <a:r>
+              <a:rPr lang="en-US" sz="1400" dirty="0"/>
+              <a:t>https://</a:t>
+            </a:r>
+            <a:r>
+              <a:rPr lang="en-US" sz="1400" dirty="0" err="1"/>
+              <a:t>media.giphy.com</a:t>
+            </a:r>
+            <a:r>
+              <a:rPr lang="en-US" sz="1400" dirty="0"/>
+              <a:t>/media/Lr3rWruv5qmWpCOXDQ/</a:t>
+            </a:r>
+            <a:r>
+              <a:rPr lang="en-US" sz="1400" dirty="0" err="1"/>
+              <a:t>giphy.gif</a:t>
+            </a:r>
+            <a:endParaRPr lang="en-US" sz="1400" dirty="0"/>
+          </a:p>
+        </p:txBody>
+      </p:sp>
+      <p:pic>
+        <p:nvPicPr>
+          <p:cNvPr id="6" name="Picture 5">
+            <a:extLst>
+              <a:ext uri="{FF2B5EF4-FFF2-40B4-BE49-F238E27FC236}">
+                <a16:creationId xmlns:a16="http://schemas.microsoft.com/office/drawing/2014/main" id="{BB014AEC-3299-6D82-CEBE-6F2E5F941F07}"/>
+              </a:ext>
+            </a:extLst>
+          </p:cNvPr>
+          <p:cNvPicPr>
+            <a:picLocks noChangeAspect="1"/>
+          </p:cNvPicPr>
+          <p:nvPr/>
+        </p:nvPicPr>
+        <p:blipFill>
+          <a:blip r:embed="rId2">
+            <a:extLst>
+              <a:ext uri="{28A0092B-C50C-407E-A947-70E740481C1C}">
+                <a14:useLocalDpi xmlns:a14="http://schemas.microsoft.com/office/drawing/2010/main" val="0"/>
+              </a:ext>
+            </a:extLst>
+          </a:blip>
+          <a:stretch>
+            <a:fillRect/>
+          </a:stretch>
+        </p:blipFill>
+        <p:spPr>
+          <a:xfrm>
+            <a:off x="1050321" y="1308731"/>
+            <a:ext cx="6576646" cy="4932485"/>
+          </a:xfrm>
+          <a:prstGeom prst="rect">
+            <a:avLst/>
+          </a:prstGeom>
+        </p:spPr>
+      </p:pic>
+      <p:sp>
+        <p:nvSpPr>
+          <p:cNvPr id="7" name="TextBox 6">
+            <a:extLst>
+              <a:ext uri="{FF2B5EF4-FFF2-40B4-BE49-F238E27FC236}">
+                <a16:creationId xmlns:a16="http://schemas.microsoft.com/office/drawing/2014/main" id="{B1F98EA0-DDAE-D05B-876A-5CF7A19122B2}"/>
+              </a:ext>
+            </a:extLst>
+          </p:cNvPr>
+          <p:cNvSpPr txBox="1"/>
+          <p:nvPr/>
+        </p:nvSpPr>
+        <p:spPr>
+          <a:xfrm>
+            <a:off x="8081318" y="3429000"/>
+            <a:ext cx="3889270" cy="2062103"/>
+          </a:xfrm>
+          <a:prstGeom prst="rect">
+            <a:avLst/>
+          </a:prstGeom>
+          <a:noFill/>
+        </p:spPr>
+        <p:txBody>
+          <a:bodyPr wrap="none" rtlCol="0">
+            <a:spAutoFit/>
+          </a:bodyPr>
+          <a:lstStyle/>
+          <a:p>
+            <a:r>
+              <a:rPr lang="en-US" sz="3200" dirty="0"/>
+              <a:t>We want to know:</a:t>
+            </a:r>
+          </a:p>
+          <a:p>
+            <a:pPr marL="285750" indent="-285750">
+              <a:buFont typeface="Arial" panose="020B0604020202020204" pitchFamily="34" charset="0"/>
+              <a:buChar char="•"/>
+            </a:pPr>
+            <a:r>
+              <a:rPr lang="en-US" sz="3200" dirty="0"/>
+              <a:t>How fast cells grow</a:t>
+            </a:r>
+          </a:p>
+          <a:p>
+            <a:pPr marL="285750" indent="-285750">
+              <a:buFont typeface="Arial" panose="020B0604020202020204" pitchFamily="34" charset="0"/>
+              <a:buChar char="•"/>
+            </a:pPr>
+            <a:r>
+              <a:rPr lang="en-US" sz="3200" dirty="0"/>
+              <a:t>When they divide</a:t>
+            </a:r>
+          </a:p>
+          <a:p>
+            <a:pPr marL="285750" indent="-285750">
+              <a:buFont typeface="Arial" panose="020B0604020202020204" pitchFamily="34" charset="0"/>
+              <a:buChar char="•"/>
+            </a:pPr>
+            <a:r>
+              <a:rPr lang="en-US" sz="3200" dirty="0"/>
+              <a:t>When they die</a:t>
+            </a:r>
+          </a:p>
+        </p:txBody>
+      </p:sp>
+    </p:spTree>
+    <p:extLst>
+      <p:ext uri="{BB962C8B-B14F-4D97-AF65-F5344CB8AC3E}">
+        <p14:creationId xmlns:p14="http://schemas.microsoft.com/office/powerpoint/2010/main" val="4225318506"/>
+      </p:ext>
+    </p:extLst>
+  </p:cSld>
+  <p:clrMapOvr>
+    <a:masterClrMapping/>
+  </p:clrMapOvr>
+</p:sld>
+</file>
+
+<file path=ppt/slides/slide3.xml><?xml version="1.0" encoding="utf-8"?>
 <p:sld xmlns:a="http://schemas.openxmlformats.org/drawingml/2006/main" xmlns:r="http://schemas.openxmlformats.org/officeDocument/2006/relationships" xmlns:p="http://schemas.openxmlformats.org/presentationml/2006/main">
   <p:cSld>
     <p:spTree>
@@ -4665,7 +4879,7 @@
 </p:sld>
 </file>
 
-<file path=ppt/slides/slide3.xml><?xml version="1.0" encoding="utf-8"?>
+<file path=ppt/slides/slide4.xml><?xml version="1.0" encoding="utf-8"?>
 <p:sld xmlns:a="http://schemas.openxmlformats.org/drawingml/2006/main" xmlns:r="http://schemas.openxmlformats.org/officeDocument/2006/relationships" xmlns:p="http://schemas.openxmlformats.org/presentationml/2006/main">
   <p:cSld>
     <p:spTree>
@@ -5768,7 +5982,7 @@
 </p:sld>
 </file>
 
-<file path=ppt/slides/slide4.xml><?xml version="1.0" encoding="utf-8"?>
+<file path=ppt/slides/slide5.xml><?xml version="1.0" encoding="utf-8"?>
 <p:sld xmlns:a="http://schemas.openxmlformats.org/drawingml/2006/main" xmlns:r="http://schemas.openxmlformats.org/officeDocument/2006/relationships" xmlns:p="http://schemas.openxmlformats.org/presentationml/2006/main">
   <p:cSld>
     <p:spTree>
@@ -6129,7 +6343,7 @@
 </p:sld>
 </file>
 
-<file path=ppt/slides/slide5.xml><?xml version="1.0" encoding="utf-8"?>
+<file path=ppt/slides/slide6.xml><?xml version="1.0" encoding="utf-8"?>
 <p:sld xmlns:a="http://schemas.openxmlformats.org/drawingml/2006/main" xmlns:r="http://schemas.openxmlformats.org/officeDocument/2006/relationships" xmlns:p="http://schemas.openxmlformats.org/presentationml/2006/main">
   <p:cSld>
     <p:spTree>
@@ -6716,7 +6930,7 @@
 </p:sld>
 </file>
 
-<file path=ppt/slides/slide6.xml><?xml version="1.0" encoding="utf-8"?>
+<file path=ppt/slides/slide7.xml><?xml version="1.0" encoding="utf-8"?>
 <p:sld xmlns:a="http://schemas.openxmlformats.org/drawingml/2006/main" xmlns:r="http://schemas.openxmlformats.org/officeDocument/2006/relationships" xmlns:p="http://schemas.openxmlformats.org/presentationml/2006/main">
   <p:cSld>
     <p:spTree>
@@ -6789,8 +7003,8 @@
         </p:nvSpPr>
         <p:spPr>
           <a:xfrm>
-            <a:off x="6446389" y="3788065"/>
-            <a:ext cx="4469522" cy="2677656"/>
+            <a:off x="6446387" y="2886022"/>
+            <a:ext cx="4469522" cy="3539430"/>
           </a:xfrm>
           <a:prstGeom prst="rect">
             <a:avLst/>
@@ -6844,6 +7058,16 @@
             <a:r>
               <a:rPr lang="en-US" sz="2800" dirty="0"/>
               <a:t>measures nuclear area</a:t>
+            </a:r>
+          </a:p>
+          <a:p>
+            <a:pPr marL="514350" indent="-514350">
+              <a:buFont typeface="+mj-lt"/>
+              <a:buAutoNum type="arabicPeriod"/>
+            </a:pPr>
+            <a:r>
+              <a:rPr lang="en-US" sz="2800" dirty="0"/>
+              <a:t>Tracks bacteria growth and death</a:t>
             </a:r>
           </a:p>
           <a:p>

</xml_diff>